<commit_message>
update: changed Rate limit from 100 to 20 and updated presentation documentation
</commit_message>
<xml_diff>
--- a/docs/AegisGate_Presentation_Final.pptx
+++ b/docs/AegisGate_Presentation_Final.pptx
@@ -5659,7 +5659,7 @@
                 <a:ea typeface="Calibri" pitchFamily="34" charset="-122"/>
                 <a:cs typeface="Calibri" pitchFamily="34" charset="-120"/>
               </a:rPr>
-              <a:t>Sub-100ms round-trip response time under high-concurrency load testing (down from ~932ms baseline), with &lt;3ms raw gateway overhead — powered by Redis hot-path caching and TCP connection pooling.</a:t>
+              <a:t>Sub-100ms round-trip response time under high-concurrency load testing (down from ~932ms baseline), with &lt;5ms raw gateway overhead — powered by Redis hot-path caching and TCP connection pooling.</a:t>
             </a:r>
             <a:endParaRPr lang="en-US" sz="1250" dirty="0"/>
           </a:p>
@@ -6298,7 +6298,7 @@
                 <a:ea typeface="Calibri" pitchFamily="34" charset="-122"/>
                 <a:cs typeface="Calibri" pitchFamily="34" charset="-120"/>
               </a:rPr>
-              <a:t>DATA PLANE · &lt;3ms</a:t>
+              <a:t>DATA PLANE · &lt;5ms</a:t>
             </a:r>
             <a:endParaRPr lang="en-US" sz="1100" dirty="0"/>
           </a:p>
@@ -6844,7 +6844,7 @@
           <p:nvPr/>
         </p:nvPicPr>
         <p:blipFill>
-          <a:blip r:embed="rId12"/>
+          <a:blip r:embed="rId6"/>
           <a:stretch>
             <a:fillRect/>
           </a:stretch>
@@ -7003,7 +7003,7 @@
           <p:nvPr/>
         </p:nvPicPr>
         <p:blipFill>
-          <a:blip r:embed="rId6"/>
+          <a:blip r:embed="rId7"/>
           <a:stretch>
             <a:fillRect/>
           </a:stretch>
@@ -7162,7 +7162,7 @@
           <p:nvPr/>
         </p:nvPicPr>
         <p:blipFill>
-          <a:blip r:embed="rId7"/>
+          <a:blip r:embed="rId8"/>
           <a:stretch>
             <a:fillRect/>
           </a:stretch>
@@ -7372,7 +7372,7 @@
           <p:nvPr/>
         </p:nvPicPr>
         <p:blipFill>
-          <a:blip r:embed="rId8"/>
+          <a:blip r:embed="rId9"/>
           <a:stretch>
             <a:fillRect/>
           </a:stretch>
@@ -7531,7 +7531,7 @@
           <p:nvPr/>
         </p:nvPicPr>
         <p:blipFill>
-          <a:blip r:embed="rId9"/>
+          <a:blip r:embed="rId10"/>
           <a:stretch>
             <a:fillRect/>
           </a:stretch>
@@ -7690,7 +7690,7 @@
           <p:nvPr/>
         </p:nvPicPr>
         <p:blipFill>
-          <a:blip r:embed="rId10"/>
+          <a:blip r:embed="rId11"/>
           <a:stretch>
             <a:fillRect/>
           </a:stretch>
@@ -7849,7 +7849,7 @@
           <p:nvPr/>
         </p:nvPicPr>
         <p:blipFill>
-          <a:blip r:embed="rId11"/>
+          <a:blip r:embed="rId12"/>
           <a:stretch>
             <a:fillRect/>
           </a:stretch>
@@ -8008,7 +8008,7 @@
           <p:nvPr/>
         </p:nvPicPr>
         <p:blipFill>
-          <a:blip r:embed="rId12"/>
+          <a:blip r:embed="rId6"/>
           <a:stretch>
             <a:fillRect/>
           </a:stretch>
@@ -9284,7 +9284,7 @@
           <p:nvPr/>
         </p:nvPicPr>
         <p:blipFill>
-          <a:blip r:embed="rId20"/>
+          <a:blip r:embed="rId6"/>
           <a:stretch>
             <a:fillRect/>
           </a:stretch>
@@ -9546,7 +9546,7 @@
           <p:nvPr/>
         </p:nvPicPr>
         <p:blipFill>
-          <a:blip r:embed="rId6"/>
+          <a:blip r:embed="rId7"/>
           <a:stretch>
             <a:fillRect/>
           </a:stretch>
@@ -9808,7 +9808,7 @@
           <p:nvPr/>
         </p:nvPicPr>
         <p:blipFill>
-          <a:blip r:embed="rId7"/>
+          <a:blip r:embed="rId8"/>
           <a:stretch>
             <a:fillRect/>
           </a:stretch>
@@ -9964,7 +9964,7 @@
                 <a:ea typeface="Cambria" pitchFamily="34" charset="-122"/>
                 <a:cs typeface="Cambria" pitchFamily="34" charset="-120"/>
               </a:rPr>
-              <a:t>&lt; 3ms  </a:t>
+              <a:t>&lt; 5ms  </a:t>
             </a:r>
             <a:r>
               <a:rPr lang="en-US" sz="1300" dirty="0">
@@ -13114,7 +13114,7 @@
           <p:nvPr/>
         </p:nvPicPr>
         <p:blipFill>
-          <a:blip r:embed="rId20"/>
+          <a:blip r:embed="rId9"/>
           <a:stretch>
             <a:fillRect/>
           </a:stretch>
@@ -14650,7 +14650,7 @@
                 <a:ea typeface="Calibri" pitchFamily="34" charset="-122"/>
                 <a:cs typeface="Calibri" pitchFamily="34" charset="-120"/>
               </a:rPr>
-              <a:t>Measured across 110-iteration concurrent load tests, with &lt;3ms raw gateway overhead and 3ms edge-blocking speed (429/403).</a:t>
+              <a:t>Measured across 110-iteration concurrent load tests, with &lt;5ms raw gateway overhead and 5ms edge-blocking speed (429/403).</a:t>
             </a:r>
             <a:endParaRPr lang="en-US" sz="1100" dirty="0"/>
           </a:p>

</xml_diff>